<commit_message>
M4: simplify presentation and spoken notes
</commit_message>
<xml_diff>
--- a/M4/report/M4_Frozen_Memory_Results.pptx
+++ b/M4/report/M4_Frozen_Memory_Results.pptx
@@ -2,14 +2,14 @@
 <file path=ppt/presentation.xml><?xml version="1.0" encoding="utf-8"?>
 <p:presentation xmlns:p="http://schemas.openxmlformats.org/presentationml/2006/main">
   <p:sldMasterIdLst>
-    <p:sldMasterId xmlns:r="http://schemas.openxmlformats.org/officeDocument/2006/relationships" id="2147483648" r:id="R25e1533a4fe745a8"/>
+    <p:sldMasterId xmlns:r="http://schemas.openxmlformats.org/officeDocument/2006/relationships" id="2147483648" r:id="Re1727be849e2431f"/>
   </p:sldMasterIdLst>
   <p:notesMasterIdLst>
-    <p:notesMasterId xmlns:r="http://schemas.openxmlformats.org/officeDocument/2006/relationships" r:id="R95b0a37239964fcc"/>
+    <p:notesMasterId xmlns:r="http://schemas.openxmlformats.org/officeDocument/2006/relationships" r:id="R7a5c5ed451b249f4"/>
   </p:notesMasterIdLst>
   <p:sldIdLst>
-    <p:sldId xmlns:r="http://schemas.openxmlformats.org/officeDocument/2006/relationships" id="256" r:id="Ra7e5b3a143714b41"/>
-    <p:sldId xmlns:r="http://schemas.openxmlformats.org/officeDocument/2006/relationships" id="257" r:id="R9919bc0a78ac4a32"/>
+    <p:sldId xmlns:r="http://schemas.openxmlformats.org/officeDocument/2006/relationships" id="256" r:id="Ra04a8149e6134b32"/>
+    <p:sldId xmlns:r="http://schemas.openxmlformats.org/officeDocument/2006/relationships" id="257" r:id="R1f35bd7d747947e0"/>
   </p:sldIdLst>
   <p:sldSz cx="12192000" cy="6858000"/>
   <p:notesSz cx="6858000" cy="9144000"/>
@@ -443,7 +443,7 @@
           <a:lstStyle xmlns:a="http://schemas.openxmlformats.org/drawingml/2006/main"/>
           <a:p xmlns:a="http://schemas.openxmlformats.org/drawingml/2006/main">
             <a:r>
-              <a:t>1: Memory and evidence management</a:t>
+              <a:t>M4 records the feedback from each queried structure, including its composition, energy and observed stability. It gives the planner a bounded selection of recent stable and unstable outcomes, with up to eight records at a time. Each episode has its own memory, and the state can be restored from a checkpoint. We also keep the full trajectory in both Memory ON and OFF runs. Generator and filter logs stay separate from planning, so turning memory off does not remove the evidence needed for analysis.</a:t>
             </a:r>
           </a:p>
           <a:p xmlns:a="http://schemas.openxmlformats.org/drawingml/2006/main">
@@ -453,27 +453,7 @@
           </a:p>
           <a:p xmlns:a="http://schemas.openxmlformats.org/drawingml/2006/main">
             <a:r>
-              <a:t>M4 stores the public feedback from each evaluated structure and supplies bounded observations to planning. Each attempt keeps its own identity and observed stability. The M1 adapter returns recent observations with contrasting outcomes, up to eight records and 4,000 JSON characters. The independent core also supports composition-distance retrieval, but the active argument-free hook uses bounded recent feedback. M3 consumes this memory. We export every official trajectory, including the final query. Separate generator and filter audit logs remain outside decision inputs and stay enabled when memory is off. Oracle exceptions are outside that capture boundary.</a:t>
-            </a:r>
-          </a:p>
-          <a:p xmlns:a="http://schemas.openxmlformats.org/drawingml/2006/main">
-            <a:r>
-              <a:t/>
-            </a:r>
-          </a:p>
-          <a:p xmlns:a="http://schemas.openxmlformats.org/drawingml/2006/main">
-            <a:r>
-              <a:t/>
-            </a:r>
-          </a:p>
-          <a:p xmlns:a="http://schemas.openxmlformats.org/drawingml/2006/main">
-            <a:r>
-              <a:t/>
-            </a:r>
-          </a:p>
-          <a:p xmlns:a="http://schemas.openxmlformats.org/drawingml/2006/main">
-            <a:r>
-              <a:t>Sources: M4/src/m4_memory/, M1/PLUGIN_INTERFACE.md. Formal evidence and limitations in M4/report/M4_FROZEN_MEMORY_RESULTS.md.</a:t>
+              <a:t>Sources: M4/src/m4_memory/ and M1/PLUGIN_INTERFACE.md.</a:t>
             </a:r>
           </a:p>
         </p:txBody>
@@ -543,7 +523,7 @@
           <a:lstStyle xmlns:a="http://schemas.openxmlformats.org/drawingml/2006/main"/>
           <a:p xmlns:a="http://schemas.openxmlformats.org/drawingml/2006/main">
             <a:r>
-              <a:t>2: Frozen Memory ablation</a:t>
+              <a:t>We tested Memory ON and OFF on six development systems with three seeds, giving 18 pairs and 36 episodes. Each episode used the same budget of 20 campaign queries. The table shows that Memory ON averaged 10.00 mSUN, compared with 9.11 for OFF. AUDC was 88.11 versus 86.94. The average mSUN difference was positive, but the effect varied: ON did better in eight pairs, tied in three and did worse in seven. We therefore describe the result as a modest average improvement rather than a consistent gain. These are development results. M1 reconstructed the ON curves from the saved trajectories, and the report records that provenance.</a:t>
             </a:r>
           </a:p>
           <a:p xmlns:a="http://schemas.openxmlformats.org/drawingml/2006/main">
@@ -553,42 +533,7 @@
           </a:p>
           <a:p xmlns:a="http://schemas.openxmlformats.org/drawingml/2006/main">
             <a:r>
-              <a:t>We compared the frozen full agent with memory disabled across six development systems and three seeds, using 20 campaign queries per episode. All 36 runs passed individual validation, and reference snapshots match. Memory ON averaged 10.00 mSUN versus 9.11 OFF. AUDC averaged 88.11 versus 86.94. The effect is mixed: ON is better in eight mSUN pairs, equal in three and worse in seven. For example, it helps on Co-Mg-Na seed 29, but concentrated Sn-Sr search loses against OFF on Mg-Sn-Sr seed 17. Memory helps some allocations but does not guarantee improvement. These results use the development split. M1 reconstructed the ON curves from frozen trajectories with documented provenance.</a:t>
-            </a:r>
-          </a:p>
-          <a:p xmlns:a="http://schemas.openxmlformats.org/drawingml/2006/main">
-            <a:r>
-              <a:t/>
-            </a:r>
-          </a:p>
-          <a:p xmlns:a="http://schemas.openxmlformats.org/drawingml/2006/main">
-            <a:r>
-              <a:t>## Sources and Q&amp;A</a:t>
-            </a:r>
-          </a:p>
-          <a:p xmlns:a="http://schemas.openxmlformats.org/drawingml/2006/main">
-            <a:r>
-              <a:t/>
-            </a:r>
-          </a:p>
-          <a:p xmlns:a="http://schemas.openxmlformats.org/drawingml/2006/main">
-            <a:r>
-              <a:t>Source table: M4/evidence/frozen-memory-ablation-20261026/paired_results.csv. Chart: analysis/aggregate_curves.csv, arithmetic mean of six systems within seed, then three seeds. Slide table rounds means to two decimals; report includes seed SD. Official AUDC uses new-stable discovery counts, a definition distinct from mSUN. Cases: analysis/TRACED_CASES.md and traced_cases.csv. Costs: analysis/per_run_cost.csv. A budgeted campaign query is one env.step; initialization adds uninstrumented oracle work. LLM cost is not reported. Exact ON consumed-memory IDs are unavailable for the formal reference. Avoid causal attribution to a specific record. All source code and evidence remain separately versioned.</a:t>
-            </a:r>
-          </a:p>
-          <a:p xmlns:a="http://schemas.openxmlformats.org/drawingml/2006/main">
-            <a:r>
-              <a:t/>
-            </a:r>
-          </a:p>
-          <a:p xmlns:a="http://schemas.openxmlformats.org/drawingml/2006/main">
-            <a:r>
-              <a:t/>
-            </a:r>
-          </a:p>
-          <a:p xmlns:a="http://schemas.openxmlformats.org/drawingml/2006/main">
-            <a:r>
-              <a:t>Chart source: M4/evidence/frozen-memory-ablation-20261026/analysis/aggregate_curves.csv. Mean of six systems within each seed, then three seed means. No SD band on this compact slide, see full report curve and table for seed SD. Native chart retains all 20 query points. Chart values round to 10 decimal places for Excel compatibility; the source CSV retains original precision.</a:t>
+              <a:t>Sources: M4/evidence/frozen-memory-ablation-20261026/paired_results.csv and analysis/aggregate_curves.csv. Means average six systems within each seed, then the three seed means. The report provides seed SD and individual cases.</a:t>
             </a:r>
           </a:p>
         </p:txBody>
@@ -3031,12 +2976,12 @@
   </p:cSld>
   <p:clrMap bg1="lt1" tx1="dk1" bg2="lt2" tx2="dk2" accent1="accent1" accent2="accent2" accent3="accent3" accent4="accent4" accent5="accent5" accent6="accent6" hlink="hlink" folHlink="folHlink"/>
   <p:sldLayoutIdLst>
-    <p:sldLayoutId xmlns:r="http://schemas.openxmlformats.org/officeDocument/2006/relationships" id="2147483649" r:id="R07c4a16997b343f7"/>
-    <p:sldLayoutId xmlns:r="http://schemas.openxmlformats.org/officeDocument/2006/relationships" id="2147483650" r:id="Rc52274a765d7481a"/>
-    <p:sldLayoutId xmlns:r="http://schemas.openxmlformats.org/officeDocument/2006/relationships" id="2147483651" r:id="Rbdb505146d4c4e27"/>
-    <p:sldLayoutId xmlns:r="http://schemas.openxmlformats.org/officeDocument/2006/relationships" id="2147483652" r:id="Rfd80575476e142ca"/>
-    <p:sldLayoutId xmlns:r="http://schemas.openxmlformats.org/officeDocument/2006/relationships" id="2147483653" r:id="Rc2ee335d95ea4737"/>
-    <p:sldLayoutId xmlns:r="http://schemas.openxmlformats.org/officeDocument/2006/relationships" id="2147483654" r:id="R47061af000a4409b"/>
+    <p:sldLayoutId xmlns:r="http://schemas.openxmlformats.org/officeDocument/2006/relationships" id="2147483649" r:id="R4eb5ee560cda4e46"/>
+    <p:sldLayoutId xmlns:r="http://schemas.openxmlformats.org/officeDocument/2006/relationships" id="2147483650" r:id="Rebc0d9fc2ded4a9c"/>
+    <p:sldLayoutId xmlns:r="http://schemas.openxmlformats.org/officeDocument/2006/relationships" id="2147483651" r:id="Rc8d0344844104f55"/>
+    <p:sldLayoutId xmlns:r="http://schemas.openxmlformats.org/officeDocument/2006/relationships" id="2147483652" r:id="R8d579818ce28406b"/>
+    <p:sldLayoutId xmlns:r="http://schemas.openxmlformats.org/officeDocument/2006/relationships" id="2147483653" r:id="R2507c6eede414917"/>
+    <p:sldLayoutId xmlns:r="http://schemas.openxmlformats.org/officeDocument/2006/relationships" id="2147483654" r:id="R4f08bf5326604d93"/>
   </p:sldLayoutIdLst>
   <p:txStyles>
     <p:titleStyle>
@@ -3568,8 +3513,8 @@
   <c:lang val="en-US"/>
   <c:chart>
     <c:plotArea>
-      <c:lineChart>
-        <c:grouping val="standard"/>
+      <c:scatterChart>
+        <c:scatterStyle val="line"/>
         <c:varyColors val="0"/>
         <c:ser>
           <c:idx val="0"/>
@@ -3584,10 +3529,7 @@
               </a:solidFill>
             </a:ln>
           </c:spPr>
-          <c:marker>
-            <c:symbol val="none"/>
-          </c:marker>
-          <c:cat>
+          <c:xVal>
             <c:numRef>
               <c:f>'Chart Data'!$A$2:$A$21</c:f>
               <c:numCache>
@@ -3655,8 +3597,8 @@
                 </c:pt>
               </c:numCache>
             </c:numRef>
-          </c:cat>
-          <c:val>
+          </c:xVal>
+          <c:yVal>
             <c:numRef>
               <c:f>'Chart Data'!$B$2:$B$21</c:f>
               <c:numCache>
@@ -3724,8 +3666,7 @@
                 </c:pt>
               </c:numCache>
             </c:numRef>
-          </c:val>
-          <c:smooth val="0"/>
+          </c:yVal>
         </c:ser>
         <c:ser>
           <c:idx val="1"/>
@@ -3740,10 +3681,7 @@
               </a:solidFill>
             </a:ln>
           </c:spPr>
-          <c:marker>
-            <c:symbol val="none"/>
-          </c:marker>
-          <c:cat>
+          <c:xVal>
             <c:numRef>
               <c:f>'Chart Data'!$C$2:$C$21</c:f>
               <c:numCache>
@@ -3811,8 +3749,8 @@
                 </c:pt>
               </c:numCache>
             </c:numRef>
-          </c:cat>
-          <c:val>
+          </c:xVal>
+          <c:yVal>
             <c:numRef>
               <c:f>'Chart Data'!$D$2:$D$21</c:f>
               <c:numCache>
@@ -3880,8 +3818,7 @@
                 </c:pt>
               </c:numCache>
             </c:numRef>
-          </c:val>
-          <c:smooth val="0"/>
+          </c:yVal>
         </c:ser>
         <c:dLbls>
           <c:txPr>
@@ -3905,78 +3842,9 @@
           <c:showBubbleSize val="0"/>
           <c:showLeaderLines val="0"/>
         </c:dLbls>
-        <c:smooth val="0"/>
         <c:axId val="48650112"/>
         <c:axId val="48672768"/>
-      </c:lineChart>
-      <c:catAx>
-        <c:axId val="48650112"/>
-        <c:scaling>
-          <c:orientation val="minMax"/>
-        </c:scaling>
-        <c:delete val="0"/>
-        <c:axPos val="b"/>
-        <c:title>
-          <c:tx>
-            <c:rich>
-              <a:bodyPr xmlns:a="http://schemas.openxmlformats.org/drawingml/2006/main"/>
-              <a:lstStyle xmlns:a="http://schemas.openxmlformats.org/drawingml/2006/main"/>
-              <a:p xmlns:a="http://schemas.openxmlformats.org/drawingml/2006/main">
-                <a:r>
-                  <a:rPr sz="1350">
-                    <a:latin typeface="Arial"/>
-                    <a:ea typeface="Arial"/>
-                    <a:cs typeface="Arial"/>
-                  </a:rPr>
-                  <a:t>Completed campaign queries</a:t>
-                </a:r>
-              </a:p>
-            </c:rich>
-          </c:tx>
-          <c:overlay val="0"/>
-          <c:txPr>
-            <a:bodyPr xmlns:a="http://schemas.openxmlformats.org/drawingml/2006/main" anchorCtr="1"/>
-            <a:lstStyle xmlns:a="http://schemas.openxmlformats.org/drawingml/2006/main"/>
-            <a:p xmlns:a="http://schemas.openxmlformats.org/drawingml/2006/main">
-              <a:pPr>
-                <a:defRPr sz="1350">
-                  <a:latin typeface="Arial"/>
-                  <a:ea typeface="Arial"/>
-                  <a:cs typeface="Arial"/>
-                </a:defRPr>
-              </a:pPr>
-            </a:p>
-          </c:txPr>
-        </c:title>
-        <c:numFmt formatCode="General"/>
-        <c:majorTickMark val="none"/>
-        <c:minorTickMark val="none"/>
-        <c:spPr>
-          <a:ln xmlns:a="http://schemas.openxmlformats.org/drawingml/2006/main" w="9525">
-            <a:solidFill>
-              <a:srgbClr val="D4D4D4"/>
-            </a:solidFill>
-            <a:prstDash val="solid"/>
-          </a:ln>
-        </c:spPr>
-        <c:txPr>
-          <a:bodyPr xmlns:a="http://schemas.openxmlformats.org/drawingml/2006/main" anchorCtr="1"/>
-          <a:lstStyle xmlns:a="http://schemas.openxmlformats.org/drawingml/2006/main"/>
-          <a:p xmlns:a="http://schemas.openxmlformats.org/drawingml/2006/main">
-            <a:pPr>
-              <a:defRPr sz="1200">
-                <a:solidFill>
-                  <a:srgbClr val="666666"/>
-                </a:solidFill>
-                <a:latin typeface="Arial"/>
-                <a:ea typeface="Arial"/>
-                <a:cs typeface="Arial"/>
-              </a:defRPr>
-            </a:pPr>
-          </a:p>
-        </c:txPr>
-        <c:crossAx val="48672768"/>
-      </c:catAx>
+      </c:scatterChart>
       <c:valAx>
         <c:axId val="48672768"/>
         <c:scaling>
@@ -4055,8 +3923,78 @@
           </a:p>
         </c:txPr>
         <c:crossAx val="48650112"/>
-        <c:crossBetween val="between"/>
         <c:majorUnit val="3"/>
+      </c:valAx>
+      <c:valAx>
+        <c:axId val="48650112"/>
+        <c:scaling>
+          <c:orientation val="minMax"/>
+          <c:max val="20"/>
+          <c:min val="0"/>
+        </c:scaling>
+        <c:delete val="0"/>
+        <c:axPos val="b"/>
+        <c:title>
+          <c:tx>
+            <c:rich>
+              <a:bodyPr xmlns:a="http://schemas.openxmlformats.org/drawingml/2006/main"/>
+              <a:lstStyle xmlns:a="http://schemas.openxmlformats.org/drawingml/2006/main"/>
+              <a:p xmlns:a="http://schemas.openxmlformats.org/drawingml/2006/main">
+                <a:r>
+                  <a:rPr sz="1350">
+                    <a:latin typeface="Arial"/>
+                    <a:ea typeface="Arial"/>
+                    <a:cs typeface="Arial"/>
+                  </a:rPr>
+                  <a:t>Completed campaign queries</a:t>
+                </a:r>
+              </a:p>
+            </c:rich>
+          </c:tx>
+          <c:overlay val="0"/>
+          <c:txPr>
+            <a:bodyPr xmlns:a="http://schemas.openxmlformats.org/drawingml/2006/main" anchorCtr="1"/>
+            <a:lstStyle xmlns:a="http://schemas.openxmlformats.org/drawingml/2006/main"/>
+            <a:p xmlns:a="http://schemas.openxmlformats.org/drawingml/2006/main">
+              <a:pPr>
+                <a:defRPr sz="1350">
+                  <a:latin typeface="Arial"/>
+                  <a:ea typeface="Arial"/>
+                  <a:cs typeface="Arial"/>
+                </a:defRPr>
+              </a:pPr>
+            </a:p>
+          </c:txPr>
+        </c:title>
+        <c:numFmt formatCode="General"/>
+        <c:majorTickMark val="none"/>
+        <c:minorTickMark val="none"/>
+        <c:spPr>
+          <a:ln xmlns:a="http://schemas.openxmlformats.org/drawingml/2006/main" w="9525">
+            <a:solidFill>
+              <a:srgbClr val="D4D4D4"/>
+            </a:solidFill>
+            <a:prstDash val="solid"/>
+          </a:ln>
+        </c:spPr>
+        <c:txPr>
+          <a:bodyPr xmlns:a="http://schemas.openxmlformats.org/drawingml/2006/main" anchorCtr="1"/>
+          <a:lstStyle xmlns:a="http://schemas.openxmlformats.org/drawingml/2006/main"/>
+          <a:p xmlns:a="http://schemas.openxmlformats.org/drawingml/2006/main">
+            <a:pPr>
+              <a:defRPr sz="1350">
+                <a:solidFill>
+                  <a:srgbClr val="666666"/>
+                </a:solidFill>
+                <a:latin typeface="Arial"/>
+                <a:ea typeface="Arial"/>
+                <a:cs typeface="Arial"/>
+              </a:defRPr>
+            </a:pPr>
+          </a:p>
+        </c:txPr>
+        <c:crossAx val="48672768"/>
+        <c:majorUnit val="5"/>
       </c:valAx>
       <c:spPr>
         <a:solidFill xmlns:a="http://schemas.openxmlformats.org/drawingml/2006/main">
@@ -4440,7 +4378,7 @@
                 <a:ea typeface="Arial"/>
                 <a:cs typeface="Arial"/>
               </a:rPr>
-              <a:t>Candidate evidence</a:t>
+              <a:t>Observed feedback</a:t>
             </a:r>
           </a:p>
         </p:txBody>
@@ -4606,31 +4544,7 @@
                 <a:ea typeface="Arial"/>
                 <a:cs typeface="Arial"/>
               </a:rPr>
-              <a:t>Run and query identity</a:t>
-            </a:r>
-          </a:p>
-          <a:p xmlns:a="http://schemas.openxmlformats.org/drawingml/2006/main">
-            <a:pPr>
-              <a:buNone/>
-              <a:defRPr sz="2100" b="0">
-                <a:solidFill>
-                  <a:srgbClr val="152A43"/>
-                </a:solidFill>
-                <a:latin typeface="Arial"/>
-                <a:ea typeface="Arial"/>
-                <a:cs typeface="Arial"/>
-              </a:defRPr>
-            </a:pPr>
-            <a:r>
-              <a:rPr sz="2100" b="0">
-                <a:solidFill>
-                  <a:srgbClr val="152A43"/>
-                </a:solidFill>
-                <a:latin typeface="Arial"/>
-                <a:ea typeface="Arial"/>
-                <a:cs typeface="Arial"/>
-              </a:rPr>
-              <a:t>Chemical system and candidate composition</a:t>
+              <a:t>Candidate composition and identity</a:t>
             </a:r>
           </a:p>
           <a:p xmlns:a="http://schemas.openxmlformats.org/drawingml/2006/main">
@@ -4678,7 +4592,7 @@
                 <a:ea typeface="Arial"/>
                 <a:cs typeface="Arial"/>
               </a:rPr>
-              <a:t>A separate record for every structure attempt</a:t>
+              <a:t>One record per queried structure</a:t>
             </a:r>
           </a:p>
         </p:txBody>
@@ -4844,7 +4758,7 @@
                 <a:ea typeface="Arial"/>
                 <a:cs typeface="Arial"/>
               </a:rPr>
-              <a:t>Bounded memory for the Planner</a:t>
+              <a:t>Memory for planning</a:t>
             </a:r>
           </a:p>
         </p:txBody>
@@ -5010,7 +4924,7 @@
                 <a:ea typeface="Arial"/>
                 <a:cs typeface="Arial"/>
               </a:rPr>
-              <a:t>Recent observations with contrasting outcomes</a:t>
+              <a:t>Recent stable and unstable outcomes</a:t>
             </a:r>
           </a:p>
           <a:p xmlns:a="http://schemas.openxmlformats.org/drawingml/2006/main">
@@ -5034,7 +4948,7 @@
                 <a:ea typeface="Arial"/>
                 <a:cs typeface="Arial"/>
               </a:rPr>
-              <a:t>Up to 8 records and 4,000 JSON characters</a:t>
+              <a:t>Up to 8 records per retrieval</a:t>
             </a:r>
           </a:p>
           <a:p xmlns:a="http://schemas.openxmlformats.org/drawingml/2006/main">
@@ -5058,7 +4972,7 @@
                 <a:ea typeface="Arial"/>
                 <a:cs typeface="Arial"/>
               </a:rPr>
-              <a:t>Episode isolation and checkpoint recovery</a:t>
+              <a:t>Separate memory for each episode</a:t>
             </a:r>
           </a:p>
         </p:txBody>
@@ -5224,7 +5138,7 @@
                 <a:ea typeface="Arial"/>
                 <a:cs typeface="Arial"/>
               </a:rPr>
-              <a:t>Complete evidence in both ON and OFF runs</a:t>
+              <a:t>Evidence stays available with Memory OFF</a:t>
             </a:r>
           </a:p>
         </p:txBody>
@@ -5390,7 +5304,7 @@
                 <a:ea typeface="Arial"/>
                 <a:cs typeface="Arial"/>
               </a:rPr>
-              <a:t>Export each official trajectory, including the final evaluation.</a:t>
+              <a:t>Both arms retain complete trajectories.</a:t>
             </a:r>
           </a:p>
           <a:p xmlns:a="http://schemas.openxmlformats.org/drawingml/2006/main">
@@ -5414,7 +5328,7 @@
                 <a:ea typeface="Arial"/>
                 <a:cs typeface="Arial"/>
               </a:rPr>
-              <a:t>Generator/filter audit logs remain separate from decision inputs.</a:t>
+              <a:t>Generator/filter logs stay separate from planning.</a:t>
             </a:r>
           </a:p>
         </p:txBody>
@@ -5580,7 +5494,7 @@
                 <a:ea typeface="Arial"/>
                 <a:cs typeface="Arial"/>
               </a:rPr>
-              <a:t>M1/M3 integration complete. Frozen dev ablation: 18 paired episodes.</a:t>
+              <a:t>18 ON/OFF pairs, 36 episodes. Development split.</a:t>
             </a:r>
           </a:p>
         </p:txBody>
@@ -6629,7 +6543,7 @@
                 <a:ea typeface="Arial"/>
                 <a:cs typeface="Arial"/>
               </a:rPr>
-              <a:t>mSUN: ON better in 8, equal in 3,</a:t>
+              <a:t>Mean difference: +0.89 mSUN</a:t>
             </a:r>
           </a:p>
           <a:p xmlns:a="http://schemas.openxmlformats.org/drawingml/2006/main">
@@ -6653,7 +6567,7 @@
                 <a:ea typeface="Arial"/>
                 <a:cs typeface="Arial"/>
               </a:rPr>
-              <a:t>worse in 7 of 18 pairs</a:t>
+              <a:t>ON better in 8 pairs, equal in 3,</a:t>
             </a:r>
           </a:p>
           <a:p xmlns:a="http://schemas.openxmlformats.org/drawingml/2006/main">
@@ -6677,7 +6591,7 @@
                 <a:ea typeface="Arial"/>
                 <a:cs typeface="Arial"/>
               </a:rPr>
-              <a:t>Small positive aggregate difference</a:t>
+              <a:t>and worse in 7</a:t>
             </a:r>
           </a:p>
         </p:txBody>
@@ -6877,7 +6791,7 @@
           <p:cNvPr id="11" name="">
             <a:extLst xmlns:a="http://schemas.openxmlformats.org/drawingml/2006/main">
               <a:ext uri="{FF2B5EF4-FFF2-40B4-BE49-F238E27FC236}">
-                <a16:creationId xmlns:a16="http://schemas.microsoft.com/office/drawing/2014/main" id="{847E9BE7-95B3-4DE8-9B25-937B2346C7E2}"/>
+                <a16:creationId xmlns:a16="http://schemas.microsoft.com/office/drawing/2014/main" id="{7AB0B37B-FE7E-4FB6-9D2F-89F06650676C}"/>
               </a:ext>
             </a:extLst>
           </p:cNvPr>
@@ -7272,7 +7186,7 @@
           <p:cNvPr id="12" name="Chart">
             <a:extLst xmlns:a="http://schemas.openxmlformats.org/drawingml/2006/main">
               <a:ext uri="{FF2B5EF4-FFF2-40B4-BE49-F238E27FC236}">
-                <a16:creationId xmlns:a16="http://schemas.microsoft.com/office/drawing/2014/main" id="{788CBC40-79B5-4430-B7B3-77E6BFC650D3}"/>
+                <a16:creationId xmlns:a16="http://schemas.microsoft.com/office/drawing/2014/main" id="{00FF1425-E3E3-4FF9-A525-89843324A225}"/>
               </a:ext>
             </a:extLst>
           </p:cNvPr>
@@ -7285,7 +7199,7 @@
         </p:xfrm>
         <a:graphic xmlns:a="http://schemas.openxmlformats.org/drawingml/2006/main">
           <a:graphicData uri="http://schemas.openxmlformats.org/drawingml/2006/chart">
-            <c:chart xmlns:r="http://schemas.openxmlformats.org/officeDocument/2006/relationships" xmlns:c="http://schemas.openxmlformats.org/drawingml/2006/chart" r:id="Ra7e07fda4ee74dc2"/>
+            <c:chart xmlns:r="http://schemas.openxmlformats.org/officeDocument/2006/relationships" xmlns:c="http://schemas.openxmlformats.org/drawingml/2006/chart" r:id="R6fd8b52deff5485d"/>
           </a:graphicData>
         </a:graphic>
       </p:graphicFrame>

</xml_diff>

<commit_message>
M4: add presenter name and clarify individual contributions
</commit_message>
<xml_diff>
--- a/M4/report/M4_Frozen_Memory_Results.pptx
+++ b/M4/report/M4_Frozen_Memory_Results.pptx
@@ -2,14 +2,14 @@
 <file path=ppt/presentation.xml><?xml version="1.0" encoding="utf-8"?>
 <p:presentation xmlns:p="http://schemas.openxmlformats.org/presentationml/2006/main">
   <p:sldMasterIdLst>
-    <p:sldMasterId xmlns:r="http://schemas.openxmlformats.org/officeDocument/2006/relationships" id="2147483648" r:id="Re1727be849e2431f"/>
+    <p:sldMasterId xmlns:r="http://schemas.openxmlformats.org/officeDocument/2006/relationships" id="2147483648" r:id="R5a84ddcbeb6a49ce"/>
   </p:sldMasterIdLst>
   <p:notesMasterIdLst>
-    <p:notesMasterId xmlns:r="http://schemas.openxmlformats.org/officeDocument/2006/relationships" r:id="R7a5c5ed451b249f4"/>
+    <p:notesMasterId xmlns:r="http://schemas.openxmlformats.org/officeDocument/2006/relationships" r:id="Reca4d5fde3c442e1"/>
   </p:notesMasterIdLst>
   <p:sldIdLst>
-    <p:sldId xmlns:r="http://schemas.openxmlformats.org/officeDocument/2006/relationships" id="256" r:id="Ra04a8149e6134b32"/>
-    <p:sldId xmlns:r="http://schemas.openxmlformats.org/officeDocument/2006/relationships" id="257" r:id="R1f35bd7d747947e0"/>
+    <p:sldId xmlns:r="http://schemas.openxmlformats.org/officeDocument/2006/relationships" id="256" r:id="Rb4eda801048f412e"/>
+    <p:sldId xmlns:r="http://schemas.openxmlformats.org/officeDocument/2006/relationships" id="257" r:id="Rb3064a7c74b04c56"/>
   </p:sldIdLst>
   <p:sldSz cx="12192000" cy="6858000"/>
   <p:notesSz cx="6858000" cy="9144000"/>
@@ -443,7 +443,7 @@
           <a:lstStyle xmlns:a="http://schemas.openxmlformats.org/drawingml/2006/main"/>
           <a:p xmlns:a="http://schemas.openxmlformats.org/drawingml/2006/main">
             <a:r>
-              <a:t>M4 records the feedback from each queried structure, including its composition, energy and observed stability. It gives the planner a bounded selection of recent stable and unstable outcomes, with up to eight records at a time. Each episode has its own memory, and the state can be restored from a checkpoint. We also keep the full trajectory in both Memory ON and OFF runs. Generator and filter logs stay separate from planning, so turning memory off does not remove the evidence needed for analysis.</a:t>
+              <a:t>My contribution was the memory and evidence-management module. It records the feedback from each queried structure, including its composition, energy and observed stability. It gives the planner a bounded selection of recent stable and unstable outcomes, with up to eight records at a time. Each episode has its own memory, and the state can be restored from a checkpoint. Both Memory ON and OFF runs retain the full trajectory. Generator and filter logs stay separate from planning, so turning memory off does not remove the evidence needed for analysis.</a:t>
             </a:r>
           </a:p>
           <a:p xmlns:a="http://schemas.openxmlformats.org/drawingml/2006/main">
@@ -523,7 +523,7 @@
           <a:lstStyle xmlns:a="http://schemas.openxmlformats.org/drawingml/2006/main"/>
           <a:p xmlns:a="http://schemas.openxmlformats.org/drawingml/2006/main">
             <a:r>
-              <a:t>We tested Memory ON and OFF on six development systems with three seeds, giving 18 pairs and 36 episodes. Each episode used the same budget of 20 campaign queries. The table shows that Memory ON averaged 10.00 mSUN, compared with 9.11 for OFF. AUDC was 88.11 versus 86.94. The average mSUN difference was positive, but the effect varied: ON did better in eight pairs, tied in three and did worse in seven. We therefore describe the result as a modest average improvement rather than a consistent gain. These are development results. M1 reconstructed the ON curves from the saved trajectories, and the report records that provenance.</a:t>
+              <a:t>I ran the 18 Memory OFF experiments and compared them with the team’s 18 frozen full-agent reference runs. The comparison covers six development systems and three seeds, giving 18 pairs and 36 episodes. Each episode used the same budget of 20 campaign queries. The table shows that Memory ON averaged 10.00 mSUN, compared with 9.11 for OFF. AUDC was 88.11 versus 86.94. The average mSUN difference was positive, but the effect varied: ON did better in eight pairs, tied in three and did worse in seven. The result shows a modest average improvement, with substantial variation across pairs. These are development results. M1 reconstructed the ON curves from the saved trajectories, and the report records that provenance.</a:t>
             </a:r>
           </a:p>
           <a:p xmlns:a="http://schemas.openxmlformats.org/drawingml/2006/main">
@@ -2976,12 +2976,12 @@
   </p:cSld>
   <p:clrMap bg1="lt1" tx1="dk1" bg2="lt2" tx2="dk2" accent1="accent1" accent2="accent2" accent3="accent3" accent4="accent4" accent5="accent5" accent6="accent6" hlink="hlink" folHlink="folHlink"/>
   <p:sldLayoutIdLst>
-    <p:sldLayoutId xmlns:r="http://schemas.openxmlformats.org/officeDocument/2006/relationships" id="2147483649" r:id="R4eb5ee560cda4e46"/>
-    <p:sldLayoutId xmlns:r="http://schemas.openxmlformats.org/officeDocument/2006/relationships" id="2147483650" r:id="Rebc0d9fc2ded4a9c"/>
-    <p:sldLayoutId xmlns:r="http://schemas.openxmlformats.org/officeDocument/2006/relationships" id="2147483651" r:id="Rc8d0344844104f55"/>
-    <p:sldLayoutId xmlns:r="http://schemas.openxmlformats.org/officeDocument/2006/relationships" id="2147483652" r:id="R8d579818ce28406b"/>
-    <p:sldLayoutId xmlns:r="http://schemas.openxmlformats.org/officeDocument/2006/relationships" id="2147483653" r:id="R2507c6eede414917"/>
-    <p:sldLayoutId xmlns:r="http://schemas.openxmlformats.org/officeDocument/2006/relationships" id="2147483654" r:id="R4f08bf5326604d93"/>
+    <p:sldLayoutId xmlns:r="http://schemas.openxmlformats.org/officeDocument/2006/relationships" id="2147483649" r:id="R7469685dc7cf4371"/>
+    <p:sldLayoutId xmlns:r="http://schemas.openxmlformats.org/officeDocument/2006/relationships" id="2147483650" r:id="R77c323a99ec740b5"/>
+    <p:sldLayoutId xmlns:r="http://schemas.openxmlformats.org/officeDocument/2006/relationships" id="2147483651" r:id="R6006027ec35544bf"/>
+    <p:sldLayoutId xmlns:r="http://schemas.openxmlformats.org/officeDocument/2006/relationships" id="2147483652" r:id="R76a7b0d0e5fc4a45"/>
+    <p:sldLayoutId xmlns:r="http://schemas.openxmlformats.org/officeDocument/2006/relationships" id="2147483653" r:id="R77111903bd6941ba"/>
+    <p:sldLayoutId xmlns:r="http://schemas.openxmlformats.org/officeDocument/2006/relationships" id="2147483654" r:id="Ra3aa54d841604cb3"/>
   </p:sldLayoutIdLst>
   <p:txStyles>
     <p:titleStyle>
@@ -5499,6 +5499,162 @@
           </a:p>
         </p:txBody>
       </p:sp>
+      <p:sp>
+        <p:nvSpPr>
+          <p:cNvPr id="10" name="">
+            <a:extLst xmlns:a="http://schemas.openxmlformats.org/drawingml/2006/main">
+              <a:ext uri="{FF2B5EF4-FFF2-40B4-BE49-F238E27FC236}">
+                <a16:creationId xmlns:a16="http://schemas.microsoft.com/office/drawing/2014/main" id="{5906CF37-BE8A-4503-9334-8A5A3DF42FF5}"/>
+              </a:ext>
+            </a:extLst>
+          </p:cNvPr>
+          <p:cNvSpPr>
+            <a:spLocks xmlns:a="http://schemas.openxmlformats.org/drawingml/2006/main" noGrp="1"/>
+          </p:cNvSpPr>
+          <p:nvPr/>
+        </p:nvSpPr>
+        <p:spPr>
+          <a:xfrm xmlns:a="http://schemas.openxmlformats.org/drawingml/2006/main">
+            <a:off x="609600" y="1123950"/>
+            <a:ext cx="4762500" cy="285750"/>
+          </a:xfrm>
+          <a:prstGeom xmlns:a="http://schemas.openxmlformats.org/drawingml/2006/main" prst="rect">
+            <a:avLst/>
+          </a:prstGeom>
+          <a:noFill xmlns:a="http://schemas.openxmlformats.org/drawingml/2006/main"/>
+          <a:ln xmlns:a="http://schemas.openxmlformats.org/drawingml/2006/main" w="0">
+            <a:noFill/>
+          </a:ln>
+        </p:spPr>
+        <p:txBody>
+          <a:bodyPr xmlns:a="http://schemas.openxmlformats.org/drawingml/2006/main"/>
+          <a:lstStyle xmlns:a="http://schemas.openxmlformats.org/drawingml/2006/main">
+            <a:defPPr>
+              <a:defRPr sz="1650">
+                <a:solidFill>
+                  <a:srgbClr val="5B6470"/>
+                </a:solidFill>
+                <a:latin typeface="Arial"/>
+                <a:ea typeface="Arial"/>
+                <a:cs typeface="Arial"/>
+              </a:defRPr>
+            </a:defPPr>
+            <a:lvl1pPr>
+              <a:defRPr sz="1650">
+                <a:solidFill>
+                  <a:srgbClr val="5B6470"/>
+                </a:solidFill>
+                <a:latin typeface="Arial"/>
+                <a:ea typeface="Arial"/>
+                <a:cs typeface="Arial"/>
+              </a:defRPr>
+            </a:lvl1pPr>
+            <a:lvl2pPr>
+              <a:defRPr sz="1650">
+                <a:solidFill>
+                  <a:srgbClr val="5B6470"/>
+                </a:solidFill>
+                <a:latin typeface="Arial"/>
+                <a:ea typeface="Arial"/>
+                <a:cs typeface="Arial"/>
+              </a:defRPr>
+            </a:lvl2pPr>
+            <a:lvl3pPr>
+              <a:defRPr sz="1650">
+                <a:solidFill>
+                  <a:srgbClr val="5B6470"/>
+                </a:solidFill>
+                <a:latin typeface="Arial"/>
+                <a:ea typeface="Arial"/>
+                <a:cs typeface="Arial"/>
+              </a:defRPr>
+            </a:lvl3pPr>
+            <a:lvl4pPr>
+              <a:defRPr sz="1650">
+                <a:solidFill>
+                  <a:srgbClr val="5B6470"/>
+                </a:solidFill>
+                <a:latin typeface="Arial"/>
+                <a:ea typeface="Arial"/>
+                <a:cs typeface="Arial"/>
+              </a:defRPr>
+            </a:lvl4pPr>
+            <a:lvl5pPr>
+              <a:defRPr sz="1650">
+                <a:solidFill>
+                  <a:srgbClr val="5B6470"/>
+                </a:solidFill>
+                <a:latin typeface="Arial"/>
+                <a:ea typeface="Arial"/>
+                <a:cs typeface="Arial"/>
+              </a:defRPr>
+            </a:lvl5pPr>
+            <a:lvl6pPr>
+              <a:defRPr sz="1650">
+                <a:solidFill>
+                  <a:srgbClr val="5B6470"/>
+                </a:solidFill>
+                <a:latin typeface="Arial"/>
+                <a:ea typeface="Arial"/>
+                <a:cs typeface="Arial"/>
+              </a:defRPr>
+            </a:lvl6pPr>
+            <a:lvl7pPr>
+              <a:defRPr sz="1650">
+                <a:solidFill>
+                  <a:srgbClr val="5B6470"/>
+                </a:solidFill>
+                <a:latin typeface="Arial"/>
+                <a:ea typeface="Arial"/>
+                <a:cs typeface="Arial"/>
+              </a:defRPr>
+            </a:lvl7pPr>
+            <a:lvl8pPr>
+              <a:defRPr sz="1650">
+                <a:solidFill>
+                  <a:srgbClr val="5B6470"/>
+                </a:solidFill>
+                <a:latin typeface="Arial"/>
+                <a:ea typeface="Arial"/>
+                <a:cs typeface="Arial"/>
+              </a:defRPr>
+            </a:lvl8pPr>
+            <a:lvl9pPr>
+              <a:defRPr sz="1650">
+                <a:solidFill>
+                  <a:srgbClr val="5B6470"/>
+                </a:solidFill>
+                <a:latin typeface="Arial"/>
+                <a:ea typeface="Arial"/>
+                <a:cs typeface="Arial"/>
+              </a:defRPr>
+            </a:lvl9pPr>
+          </a:lstStyle>
+          <a:p xmlns:a="http://schemas.openxmlformats.org/drawingml/2006/main">
+            <a:pPr>
+              <a:defRPr sz="1650">
+                <a:solidFill>
+                  <a:srgbClr val="5B6470"/>
+                </a:solidFill>
+                <a:latin typeface="Arial"/>
+                <a:ea typeface="Arial"/>
+                <a:cs typeface="Arial"/>
+              </a:defRPr>
+            </a:pPr>
+            <a:r>
+              <a:rPr sz="1650">
+                <a:solidFill>
+                  <a:srgbClr val="5B6470"/>
+                </a:solidFill>
+                <a:latin typeface="Arial"/>
+                <a:ea typeface="Arial"/>
+                <a:cs typeface="Arial"/>
+              </a:rPr>
+              <a:t>Zhang Yiming</a:t>
+            </a:r>
+          </a:p>
+        </p:txBody>
+      </p:sp>
     </p:spTree>
     <p:extLst>
       <p:ext uri="{BB962C8B-B14F-4D97-AF65-F5344CB8AC3E}">
@@ -6791,7 +6947,7 @@
           <p:cNvPr id="11" name="">
             <a:extLst xmlns:a="http://schemas.openxmlformats.org/drawingml/2006/main">
               <a:ext uri="{FF2B5EF4-FFF2-40B4-BE49-F238E27FC236}">
-                <a16:creationId xmlns:a16="http://schemas.microsoft.com/office/drawing/2014/main" id="{7AB0B37B-FE7E-4FB6-9D2F-89F06650676C}"/>
+                <a16:creationId xmlns:a16="http://schemas.microsoft.com/office/drawing/2014/main" id="{DF2C0D89-0CEC-4BAD-9FED-FCF4BB100B67}"/>
               </a:ext>
             </a:extLst>
           </p:cNvPr>
@@ -7186,7 +7342,7 @@
           <p:cNvPr id="12" name="Chart">
             <a:extLst xmlns:a="http://schemas.openxmlformats.org/drawingml/2006/main">
               <a:ext uri="{FF2B5EF4-FFF2-40B4-BE49-F238E27FC236}">
-                <a16:creationId xmlns:a16="http://schemas.microsoft.com/office/drawing/2014/main" id="{00FF1425-E3E3-4FF9-A525-89843324A225}"/>
+                <a16:creationId xmlns:a16="http://schemas.microsoft.com/office/drawing/2014/main" id="{1C8A8AAE-0FED-4081-BAC1-1E5172D84038}"/>
               </a:ext>
             </a:extLst>
           </p:cNvPr>
@@ -7199,7 +7355,7 @@
         </p:xfrm>
         <a:graphic xmlns:a="http://schemas.openxmlformats.org/drawingml/2006/main">
           <a:graphicData uri="http://schemas.openxmlformats.org/drawingml/2006/chart">
-            <c:chart xmlns:r="http://schemas.openxmlformats.org/officeDocument/2006/relationships" xmlns:c="http://schemas.openxmlformats.org/drawingml/2006/chart" r:id="R6fd8b52deff5485d"/>
+            <c:chart xmlns:r="http://schemas.openxmlformats.org/officeDocument/2006/relationships" xmlns:c="http://schemas.openxmlformats.org/drawingml/2006/chart" r:id="Rcb2c71c8104e4170"/>
           </a:graphicData>
         </a:graphic>
       </p:graphicFrame>

</xml_diff>

<commit_message>
M4: identify presenter in embedded slide notes
</commit_message>
<xml_diff>
--- a/M4/report/M4_Frozen_Memory_Results.pptx
+++ b/M4/report/M4_Frozen_Memory_Results.pptx
@@ -2,14 +2,14 @@
 <file path=ppt/presentation.xml><?xml version="1.0" encoding="utf-8"?>
 <p:presentation xmlns:p="http://schemas.openxmlformats.org/presentationml/2006/main">
   <p:sldMasterIdLst>
-    <p:sldMasterId xmlns:r="http://schemas.openxmlformats.org/officeDocument/2006/relationships" id="2147483648" r:id="R5a84ddcbeb6a49ce"/>
+    <p:sldMasterId xmlns:r="http://schemas.openxmlformats.org/officeDocument/2006/relationships" id="2147483648" r:id="R5be012b080ea4ec6"/>
   </p:sldMasterIdLst>
   <p:notesMasterIdLst>
-    <p:notesMasterId xmlns:r="http://schemas.openxmlformats.org/officeDocument/2006/relationships" r:id="Reca4d5fde3c442e1"/>
+    <p:notesMasterId xmlns:r="http://schemas.openxmlformats.org/officeDocument/2006/relationships" r:id="R51bc7a323a534cff"/>
   </p:notesMasterIdLst>
   <p:sldIdLst>
-    <p:sldId xmlns:r="http://schemas.openxmlformats.org/officeDocument/2006/relationships" id="256" r:id="Rb4eda801048f412e"/>
-    <p:sldId xmlns:r="http://schemas.openxmlformats.org/officeDocument/2006/relationships" id="257" r:id="Rb3064a7c74b04c56"/>
+    <p:sldId xmlns:r="http://schemas.openxmlformats.org/officeDocument/2006/relationships" id="256" r:id="Rd15b7921f2be409d"/>
+    <p:sldId xmlns:r="http://schemas.openxmlformats.org/officeDocument/2006/relationships" id="257" r:id="Rf433e7da3d6749f6"/>
   </p:sldIdLst>
   <p:sldSz cx="12192000" cy="6858000"/>
   <p:notesSz cx="6858000" cy="9144000"/>
@@ -443,6 +443,16 @@
           <a:lstStyle xmlns:a="http://schemas.openxmlformats.org/drawingml/2006/main"/>
           <a:p xmlns:a="http://schemas.openxmlformats.org/drawingml/2006/main">
             <a:r>
+              <a:t>Presenter: Zhang Yiming</a:t>
+            </a:r>
+          </a:p>
+          <a:p xmlns:a="http://schemas.openxmlformats.org/drawingml/2006/main">
+            <a:r>
+              <a:t/>
+            </a:r>
+          </a:p>
+          <a:p xmlns:a="http://schemas.openxmlformats.org/drawingml/2006/main">
+            <a:r>
               <a:t>My contribution was the memory and evidence-management module. It records the feedback from each queried structure, including its composition, energy and observed stability. It gives the planner a bounded selection of recent stable and unstable outcomes, with up to eight records at a time. Each episode has its own memory, and the state can be restored from a checkpoint. Both Memory ON and OFF runs retain the full trajectory. Generator and filter logs stay separate from planning, so turning memory off does not remove the evidence needed for analysis.</a:t>
             </a:r>
           </a:p>
@@ -521,6 +531,16 @@
         <p:txBody>
           <a:bodyPr xmlns:a="http://schemas.openxmlformats.org/drawingml/2006/main"/>
           <a:lstStyle xmlns:a="http://schemas.openxmlformats.org/drawingml/2006/main"/>
+          <a:p xmlns:a="http://schemas.openxmlformats.org/drawingml/2006/main">
+            <a:r>
+              <a:t>Presenter: Zhang Yiming</a:t>
+            </a:r>
+          </a:p>
+          <a:p xmlns:a="http://schemas.openxmlformats.org/drawingml/2006/main">
+            <a:r>
+              <a:t/>
+            </a:r>
+          </a:p>
           <a:p xmlns:a="http://schemas.openxmlformats.org/drawingml/2006/main">
             <a:r>
               <a:t>I ran the 18 Memory OFF experiments and compared them with the team’s 18 frozen full-agent reference runs. The comparison covers six development systems and three seeds, giving 18 pairs and 36 episodes. Each episode used the same budget of 20 campaign queries. The table shows that Memory ON averaged 10.00 mSUN, compared with 9.11 for OFF. AUDC was 88.11 versus 86.94. The average mSUN difference was positive, but the effect varied: ON did better in eight pairs, tied in three and did worse in seven. The result shows a modest average improvement, with substantial variation across pairs. These are development results. M1 reconstructed the ON curves from the saved trajectories, and the report records that provenance.</a:t>
@@ -2976,12 +2996,12 @@
   </p:cSld>
   <p:clrMap bg1="lt1" tx1="dk1" bg2="lt2" tx2="dk2" accent1="accent1" accent2="accent2" accent3="accent3" accent4="accent4" accent5="accent5" accent6="accent6" hlink="hlink" folHlink="folHlink"/>
   <p:sldLayoutIdLst>
-    <p:sldLayoutId xmlns:r="http://schemas.openxmlformats.org/officeDocument/2006/relationships" id="2147483649" r:id="R7469685dc7cf4371"/>
-    <p:sldLayoutId xmlns:r="http://schemas.openxmlformats.org/officeDocument/2006/relationships" id="2147483650" r:id="R77c323a99ec740b5"/>
-    <p:sldLayoutId xmlns:r="http://schemas.openxmlformats.org/officeDocument/2006/relationships" id="2147483651" r:id="R6006027ec35544bf"/>
-    <p:sldLayoutId xmlns:r="http://schemas.openxmlformats.org/officeDocument/2006/relationships" id="2147483652" r:id="R76a7b0d0e5fc4a45"/>
-    <p:sldLayoutId xmlns:r="http://schemas.openxmlformats.org/officeDocument/2006/relationships" id="2147483653" r:id="R77111903bd6941ba"/>
-    <p:sldLayoutId xmlns:r="http://schemas.openxmlformats.org/officeDocument/2006/relationships" id="2147483654" r:id="Ra3aa54d841604cb3"/>
+    <p:sldLayoutId xmlns:r="http://schemas.openxmlformats.org/officeDocument/2006/relationships" id="2147483649" r:id="Rda1c118f552f49a7"/>
+    <p:sldLayoutId xmlns:r="http://schemas.openxmlformats.org/officeDocument/2006/relationships" id="2147483650" r:id="R011d0c9b440e4ef3"/>
+    <p:sldLayoutId xmlns:r="http://schemas.openxmlformats.org/officeDocument/2006/relationships" id="2147483651" r:id="R7baee7a9a0144569"/>
+    <p:sldLayoutId xmlns:r="http://schemas.openxmlformats.org/officeDocument/2006/relationships" id="2147483652" r:id="R32e2331c28294e35"/>
+    <p:sldLayoutId xmlns:r="http://schemas.openxmlformats.org/officeDocument/2006/relationships" id="2147483653" r:id="R67ceb7f776494e91"/>
+    <p:sldLayoutId xmlns:r="http://schemas.openxmlformats.org/officeDocument/2006/relationships" id="2147483654" r:id="Re2219c22ec174c94"/>
   </p:sldLayoutIdLst>
   <p:txStyles>
     <p:titleStyle>
@@ -5540,6 +5560,7 @@
               </a:defRPr>
             </a:defPPr>
             <a:lvl1pPr>
+              <a:buNone/>
               <a:defRPr sz="1650">
                 <a:solidFill>
                   <a:srgbClr val="5B6470"/>
@@ -5550,6 +5571,7 @@
               </a:defRPr>
             </a:lvl1pPr>
             <a:lvl2pPr>
+              <a:buNone/>
               <a:defRPr sz="1650">
                 <a:solidFill>
                   <a:srgbClr val="5B6470"/>
@@ -5560,6 +5582,7 @@
               </a:defRPr>
             </a:lvl2pPr>
             <a:lvl3pPr>
+              <a:buNone/>
               <a:defRPr sz="1650">
                 <a:solidFill>
                   <a:srgbClr val="5B6470"/>
@@ -5570,6 +5593,7 @@
               </a:defRPr>
             </a:lvl3pPr>
             <a:lvl4pPr>
+              <a:buNone/>
               <a:defRPr sz="1650">
                 <a:solidFill>
                   <a:srgbClr val="5B6470"/>
@@ -5580,6 +5604,7 @@
               </a:defRPr>
             </a:lvl4pPr>
             <a:lvl5pPr>
+              <a:buNone/>
               <a:defRPr sz="1650">
                 <a:solidFill>
                   <a:srgbClr val="5B6470"/>
@@ -5590,6 +5615,7 @@
               </a:defRPr>
             </a:lvl5pPr>
             <a:lvl6pPr>
+              <a:buNone/>
               <a:defRPr sz="1650">
                 <a:solidFill>
                   <a:srgbClr val="5B6470"/>
@@ -5600,6 +5626,7 @@
               </a:defRPr>
             </a:lvl6pPr>
             <a:lvl7pPr>
+              <a:buNone/>
               <a:defRPr sz="1650">
                 <a:solidFill>
                   <a:srgbClr val="5B6470"/>
@@ -5610,6 +5637,7 @@
               </a:defRPr>
             </a:lvl7pPr>
             <a:lvl8pPr>
+              <a:buNone/>
               <a:defRPr sz="1650">
                 <a:solidFill>
                   <a:srgbClr val="5B6470"/>
@@ -5620,6 +5648,7 @@
               </a:defRPr>
             </a:lvl8pPr>
             <a:lvl9pPr>
+              <a:buNone/>
               <a:defRPr sz="1650">
                 <a:solidFill>
                   <a:srgbClr val="5B6470"/>
@@ -5632,6 +5661,7 @@
           </a:lstStyle>
           <a:p xmlns:a="http://schemas.openxmlformats.org/drawingml/2006/main">
             <a:pPr>
+              <a:buNone/>
               <a:defRPr sz="1650">
                 <a:solidFill>
                   <a:srgbClr val="5B6470"/>
@@ -6947,7 +6977,7 @@
           <p:cNvPr id="11" name="">
             <a:extLst xmlns:a="http://schemas.openxmlformats.org/drawingml/2006/main">
               <a:ext uri="{FF2B5EF4-FFF2-40B4-BE49-F238E27FC236}">
-                <a16:creationId xmlns:a16="http://schemas.microsoft.com/office/drawing/2014/main" id="{DF2C0D89-0CEC-4BAD-9FED-FCF4BB100B67}"/>
+                <a16:creationId xmlns:a16="http://schemas.microsoft.com/office/drawing/2014/main" id="{92965255-EE03-42EF-A6EE-F44200E3B448}"/>
               </a:ext>
             </a:extLst>
           </p:cNvPr>
@@ -7342,7 +7372,7 @@
           <p:cNvPr id="12" name="Chart">
             <a:extLst xmlns:a="http://schemas.openxmlformats.org/drawingml/2006/main">
               <a:ext uri="{FF2B5EF4-FFF2-40B4-BE49-F238E27FC236}">
-                <a16:creationId xmlns:a16="http://schemas.microsoft.com/office/drawing/2014/main" id="{1C8A8AAE-0FED-4081-BAC1-1E5172D84038}"/>
+                <a16:creationId xmlns:a16="http://schemas.microsoft.com/office/drawing/2014/main" id="{0B7EB4E4-CAD2-4F4A-81B2-6D3CB40714B6}"/>
               </a:ext>
             </a:extLst>
           </p:cNvPr>
@@ -7355,7 +7385,7 @@
         </p:xfrm>
         <a:graphic xmlns:a="http://schemas.openxmlformats.org/drawingml/2006/main">
           <a:graphicData uri="http://schemas.openxmlformats.org/drawingml/2006/chart">
-            <c:chart xmlns:r="http://schemas.openxmlformats.org/officeDocument/2006/relationships" xmlns:c="http://schemas.openxmlformats.org/drawingml/2006/chart" r:id="Rcb2c71c8104e4170"/>
+            <c:chart xmlns:r="http://schemas.openxmlformats.org/officeDocument/2006/relationships" xmlns:c="http://schemas.openxmlformats.org/drawingml/2006/chart" r:id="R956cea626d23408f"/>
           </a:graphicData>
         </a:graphic>
       </p:graphicFrame>

</xml_diff>